<commit_message>
docs: feature FinCompliance as the agent project
</commit_message>
<xml_diff>
--- a/artifacts/AI-Inference-Developer-Portfolio.pptx
+++ b/artifacts/AI-Inference-Developer-Portfolio.pptx
@@ -3531,7 +3531,7 @@
         <p:spPr>
           <a:xfrm>
             <a:off x="6592824" y="4919472"/>
-            <a:ext cx="1645920" cy="393192"/>
+            <a:ext cx="1824228" cy="393192"/>
           </a:xfrm>
           <a:prstGeom prst="roundRect">
             <a:avLst/>
@@ -3576,7 +3576,7 @@
         <p:spPr>
           <a:xfrm>
             <a:off x="6693408" y="5038344"/>
-            <a:ext cx="1444752" cy="155448"/>
+            <a:ext cx="1623060" cy="155448"/>
           </a:xfrm>
           <a:prstGeom prst="rect">
             <a:avLst/>
@@ -3605,7 +3605,7 @@
                 <a:latin typeface="Noto Sans KR"/>
                 <a:ea typeface="Noto Sans KR"/>
               </a:rPr>
-              <a:t>EvidenceOps Agent</a:t>
+              <a:t>FinCompliance Agent</a:t>
             </a:r>
           </a:p>
         </p:txBody>
@@ -3717,7 +3717,7 @@
                 <a:latin typeface="Noto Sans KR"/>
                 <a:ea typeface="Noto Sans KR"/>
               </a:rPr>
-              <a:t>EVIDENCEOPS · VERIFIED RESULT</a:t>
+              <a:t>FINCOMPLIANCE · VERIFIED CONTROLS</a:t>
             </a:r>
           </a:p>
         </p:txBody>
@@ -3760,7 +3760,7 @@
                 <a:latin typeface="Noto Sans KR"/>
                 <a:ea typeface="Noto Sans KR"/>
               </a:rPr>
-              <a:t>실행보다 중요한 것은 증거와 중단 경계</a:t>
+              <a:t>Tool hallucination과 권한 경계를 회귀 테스트</a:t>
             </a:r>
           </a:p>
         </p:txBody>
@@ -3803,7 +3803,7 @@
                 <a:latin typeface="Noto Sans KR"/>
                 <a:ea typeface="Noto Sans KR"/>
               </a:rPr>
-              <a:t>세 프로젝트의 계약을 한 큐에서 검증하고 실행 사건을 SHA-256 hash chain으로 연결했습니다.</a:t>
+              <a:t>모델 선택을 결정적으로 재생하되 실제 tool registry·state·guardrail 경로를 그대로 통과시켰습니다.</a:t>
             </a:r>
           </a:p>
         </p:txBody>
@@ -3938,7 +3938,7 @@
                           <a:latin typeface="DejaVu Sans Mono"/>
                           <a:ea typeface="DejaVu Sans Mono"/>
                         </a:rPr>
-                        <a:t>실측 결과</a:t>
+                        <a:t>검증 결과</a:t>
                       </a:r>
                     </a:p>
                   </a:txBody>
@@ -3988,7 +3988,7 @@
                           <a:latin typeface="Noto Sans KR"/>
                           <a:ea typeface="Noto Sans KR"/>
                         </a:rPr>
-                        <a:t>Agent run</a:t>
+                        <a:t>Tool call</a:t>
                       </a:r>
                     </a:p>
                   </a:txBody>
@@ -4012,7 +4012,7 @@
                           <a:latin typeface="DejaVu Sans Mono"/>
                           <a:ea typeface="DejaVu Sans Mono"/>
                         </a:rPr>
-                        <a:t>10-state machine + checkpoint</a:t>
+                        <a:t>allowlist + strict JSON schema</a:t>
                       </a:r>
                     </a:p>
                   </a:txBody>
@@ -4036,7 +4036,7 @@
                           <a:latin typeface="DejaVu Sans Mono"/>
                           <a:ea typeface="DejaVu Sans Mono"/>
                         </a:rPr>
-                        <a:t>6 / 6 jobs PASS</a:t>
+                        <a:t>12 / 12 control PASS</a:t>
                       </a:r>
                     </a:p>
                   </a:txBody>
@@ -4060,203 +4060,7 @@
                           <a:latin typeface="DejaVu Sans Mono"/>
                           <a:ea typeface="DejaVu Sans Mono"/>
                         </a:rPr>
-                        <a:t>완료 job 재실행 금지</a:t>
-                      </a:r>
-                    </a:p>
-                  </a:txBody>
-                  <a:tcPr marL="82296" marR="82296" marT="45720" marB="45720">
-                    <a:solidFill>
-                      <a:srgbClr val="0E1D30"/>
-                    </a:solidFill>
-                  </a:tcPr>
-                </a:tc>
-              </a:tr>
-              <a:tr h="597408">
-                <a:tc>
-                  <a:txBody>
-                    <a:bodyPr/>
-                    <a:lstStyle/>
-                    <a:p>
-                      <a:pPr algn="l"/>
-                      <a:r>
-                        <a:rPr sz="1050" b="0" lang="ko-KR">
-                          <a:solidFill>
-                            <a:srgbClr val="F3F7FD"/>
-                          </a:solidFill>
-                          <a:latin typeface="Noto Sans KR"/>
-                          <a:ea typeface="Noto Sans KR"/>
-                        </a:rPr>
-                        <a:t>Execution</a:t>
-                      </a:r>
-                    </a:p>
-                  </a:txBody>
-                  <a:tcPr marL="82296" marR="82296" marT="45720" marB="45720">
-                    <a:solidFill>
-                      <a:srgbClr val="0E1D30"/>
-                    </a:solidFill>
-                  </a:tcPr>
-                </a:tc>
-                <a:tc>
-                  <a:txBody>
-                    <a:bodyPr/>
-                    <a:lstStyle/>
-                    <a:p>
-                      <a:pPr algn="ctr"/>
-                      <a:r>
-                        <a:rPr sz="1050" b="0" lang="ko-KR">
-                          <a:solidFill>
-                            <a:srgbClr val="9AF56D"/>
-                          </a:solidFill>
-                          <a:latin typeface="DejaVu Sans Mono"/>
-                          <a:ea typeface="DejaVu Sans Mono"/>
-                        </a:rPr>
-                        <a:t>sequential queue + detach</a:t>
-                      </a:r>
-                    </a:p>
-                  </a:txBody>
-                  <a:tcPr marL="82296" marR="82296" marT="45720" marB="45720">
-                    <a:solidFill>
-                      <a:srgbClr val="0E1D30"/>
-                    </a:solidFill>
-                  </a:tcPr>
-                </a:tc>
-                <a:tc>
-                  <a:txBody>
-                    <a:bodyPr/>
-                    <a:lstStyle/>
-                    <a:p>
-                      <a:pPr algn="ctr"/>
-                      <a:r>
-                        <a:rPr sz="1050" b="0" lang="ko-KR">
-                          <a:solidFill>
-                            <a:srgbClr val="9AF56D"/>
-                          </a:solidFill>
-                          <a:latin typeface="DejaVu Sans Mono"/>
-                          <a:ea typeface="DejaVu Sans Mono"/>
-                        </a:rPr>
-                        <a:t>14.460s</a:t>
-                      </a:r>
-                    </a:p>
-                  </a:txBody>
-                  <a:tcPr marL="82296" marR="82296" marT="45720" marB="45720">
-                    <a:solidFill>
-                      <a:srgbClr val="0E1D30"/>
-                    </a:solidFill>
-                  </a:tcPr>
-                </a:tc>
-                <a:tc>
-                  <a:txBody>
-                    <a:bodyPr/>
-                    <a:lstStyle/>
-                    <a:p>
-                      <a:pPr algn="ctr"/>
-                      <a:r>
-                        <a:rPr sz="1050" b="0" lang="ko-KR">
-                          <a:solidFill>
-                            <a:srgbClr val="9AF56D"/>
-                          </a:solidFill>
-                          <a:latin typeface="DejaVu Sans Mono"/>
-                          <a:ea typeface="DejaVu Sans Mono"/>
-                        </a:rPr>
-                        <a:t>interruption 후 resume</a:t>
-                      </a:r>
-                    </a:p>
-                  </a:txBody>
-                  <a:tcPr marL="82296" marR="82296" marT="45720" marB="45720">
-                    <a:solidFill>
-                      <a:srgbClr val="0E1D30"/>
-                    </a:solidFill>
-                  </a:tcPr>
-                </a:tc>
-              </a:tr>
-              <a:tr h="597408">
-                <a:tc>
-                  <a:txBody>
-                    <a:bodyPr/>
-                    <a:lstStyle/>
-                    <a:p>
-                      <a:pPr algn="l"/>
-                      <a:r>
-                        <a:rPr sz="1050" b="0" lang="ko-KR">
-                          <a:solidFill>
-                            <a:srgbClr val="F3F7FD"/>
-                          </a:solidFill>
-                          <a:latin typeface="Noto Sans KR"/>
-                          <a:ea typeface="Noto Sans KR"/>
-                        </a:rPr>
-                        <a:t>Resource</a:t>
-                      </a:r>
-                    </a:p>
-                  </a:txBody>
-                  <a:tcPr marL="82296" marR="82296" marT="45720" marB="45720">
-                    <a:solidFill>
-                      <a:srgbClr val="0E1D30"/>
-                    </a:solidFill>
-                  </a:tcPr>
-                </a:tc>
-                <a:tc>
-                  <a:txBody>
-                    <a:bodyPr/>
-                    <a:lstStyle/>
-                    <a:p>
-                      <a:pPr algn="ctr"/>
-                      <a:r>
-                        <a:rPr sz="1050" b="0" lang="ko-KR">
-                          <a:solidFill>
-                            <a:srgbClr val="9AF56D"/>
-                          </a:solidFill>
-                          <a:latin typeface="DejaVu Sans Mono"/>
-                          <a:ea typeface="DejaVu Sans Mono"/>
-                        </a:rPr>
-                        <a:t>physical GPU 1 exclusive</a:t>
-                      </a:r>
-                    </a:p>
-                  </a:txBody>
-                  <a:tcPr marL="82296" marR="82296" marT="45720" marB="45720">
-                    <a:solidFill>
-                      <a:srgbClr val="0E1D30"/>
-                    </a:solidFill>
-                  </a:tcPr>
-                </a:tc>
-                <a:tc>
-                  <a:txBody>
-                    <a:bodyPr/>
-                    <a:lstStyle/>
-                    <a:p>
-                      <a:pPr algn="ctr"/>
-                      <a:r>
-                        <a:rPr sz="1050" b="0" lang="ko-KR">
-                          <a:solidFill>
-                            <a:srgbClr val="9AF56D"/>
-                          </a:solidFill>
-                          <a:latin typeface="DejaVu Sans Mono"/>
-                          <a:ea typeface="DejaVu Sans Mono"/>
-                        </a:rPr>
-                        <a:t>GPU executions 0</a:t>
-                      </a:r>
-                    </a:p>
-                  </a:txBody>
-                  <a:tcPr marL="82296" marR="82296" marT="45720" marB="45720">
-                    <a:solidFill>
-                      <a:srgbClr val="0E1D30"/>
-                    </a:solidFill>
-                  </a:tcPr>
-                </a:tc>
-                <a:tc>
-                  <a:txBody>
-                    <a:bodyPr/>
-                    <a:lstStyle/>
-                    <a:p>
-                      <a:pPr algn="ctr"/>
-                      <a:r>
-                        <a:rPr sz="1050" b="0" lang="ko-KR">
-                          <a:solidFill>
-                            <a:srgbClr val="9AF56D"/>
-                          </a:solidFill>
-                          <a:latin typeface="DejaVu Sans Mono"/>
-                          <a:ea typeface="DejaVu Sans Mono"/>
-                        </a:rPr>
-                        <a:t>CPU에서 CUDA 비노출</a:t>
+                        <a:t>없는 도구·인자 차단</a:t>
                       </a:r>
                     </a:p>
                   </a:txBody>
@@ -4306,7 +4110,7 @@
                           <a:latin typeface="DejaVu Sans Mono"/>
                           <a:ea typeface="DejaVu Sans Mono"/>
                         </a:rPr>
-                        <a:t>log hash + audit chain</a:t>
+                        <a:t>returned citation allowlist</a:t>
                       </a:r>
                     </a:p>
                   </a:txBody>
@@ -4330,7 +4134,7 @@
                           <a:latin typeface="DejaVu Sans Mono"/>
                           <a:ea typeface="DejaVu Sans Mono"/>
                         </a:rPr>
-                        <a:t>VERIFIED</a:t>
+                        <a:t>grounded normal flow</a:t>
                       </a:r>
                     </a:p>
                   </a:txBody>
@@ -4354,7 +4158,7 @@
                           <a:latin typeface="DejaVu Sans Mono"/>
                           <a:ea typeface="DejaVu Sans Mono"/>
                         </a:rPr>
-                        <a:t>변조 시 chain 검증 실패</a:t>
+                        <a:t>가짜 규정 ID 탐지</a:t>
                       </a:r>
                     </a:p>
                   </a:txBody>
@@ -4380,7 +4184,7 @@
                           <a:latin typeface="Noto Sans KR"/>
                           <a:ea typeface="Noto Sans KR"/>
                         </a:rPr>
-                        <a:t>Interface</a:t>
+                        <a:t>Security</a:t>
                       </a:r>
                     </a:p>
                   </a:txBody>
@@ -4404,7 +4208,7 @@
                           <a:latin typeface="DejaVu Sans Mono"/>
                           <a:ea typeface="DejaVu Sans Mono"/>
                         </a:rPr>
-                        <a:t>CLI + MCP v2</a:t>
+                        <a:t>untrusted output sanitizer</a:t>
                       </a:r>
                     </a:p>
                   </a:txBody>
@@ -4428,7 +4232,7 @@
                           <a:latin typeface="DejaVu Sans Mono"/>
                           <a:ea typeface="DejaVu Sans Mono"/>
                         </a:rPr>
-                        <a:t>7 tools</a:t>
+                        <a:t>injection neutralized</a:t>
                       </a:r>
                     </a:p>
                   </a:txBody>
@@ -4452,7 +4256,203 @@
                           <a:latin typeface="DejaVu Sans Mono"/>
                           <a:ea typeface="DejaVu Sans Mono"/>
                         </a:rPr>
-                        <a:t>policy 우회 경로 없음</a:t>
+                        <a:t>도구 출력 명령 미실행</a:t>
+                      </a:r>
+                    </a:p>
+                  </a:txBody>
+                  <a:tcPr marL="82296" marR="82296" marT="45720" marB="45720">
+                    <a:solidFill>
+                      <a:srgbClr val="0E1D30"/>
+                    </a:solidFill>
+                  </a:tcPr>
+                </a:tc>
+              </a:tr>
+              <a:tr h="597408">
+                <a:tc>
+                  <a:txBody>
+                    <a:bodyPr/>
+                    <a:lstStyle/>
+                    <a:p>
+                      <a:pPr algn="l"/>
+                      <a:r>
+                        <a:rPr sz="1050" b="0" lang="ko-KR">
+                          <a:solidFill>
+                            <a:srgbClr val="F3F7FD"/>
+                          </a:solidFill>
+                          <a:latin typeface="Noto Sans KR"/>
+                          <a:ea typeface="Noto Sans KR"/>
+                        </a:rPr>
+                        <a:t>Authority</a:t>
+                      </a:r>
+                    </a:p>
+                  </a:txBody>
+                  <a:tcPr marL="82296" marR="82296" marT="45720" marB="45720">
+                    <a:solidFill>
+                      <a:srgbClr val="0E1D30"/>
+                    </a:solidFill>
+                  </a:tcPr>
+                </a:tc>
+                <a:tc>
+                  <a:txBody>
+                    <a:bodyPr/>
+                    <a:lstStyle/>
+                    <a:p>
+                      <a:pPr algn="ctr"/>
+                      <a:r>
+                        <a:rPr sz="1050" b="0" lang="ko-KR">
+                          <a:solidFill>
+                            <a:srgbClr val="9AF56D"/>
+                          </a:solidFill>
+                          <a:latin typeface="DejaVu Sans Mono"/>
+                          <a:ea typeface="DejaVu Sans Mono"/>
+                        </a:rPr>
+                        <a:t>out-of-band single-use token</a:t>
+                      </a:r>
+                    </a:p>
+                  </a:txBody>
+                  <a:tcPr marL="82296" marR="82296" marT="45720" marB="45720">
+                    <a:solidFill>
+                      <a:srgbClr val="0E1D30"/>
+                    </a:solidFill>
+                  </a:tcPr>
+                </a:tc>
+                <a:tc>
+                  <a:txBody>
+                    <a:bodyPr/>
+                    <a:lstStyle/>
+                    <a:p>
+                      <a:pPr algn="ctr"/>
+                      <a:r>
+                        <a:rPr sz="1050" b="0" lang="ko-KR">
+                          <a:solidFill>
+                            <a:srgbClr val="9AF56D"/>
+                          </a:solidFill>
+                          <a:latin typeface="DejaVu Sans Mono"/>
+                          <a:ea typeface="DejaVu Sans Mono"/>
+                        </a:rPr>
+                        <a:t>unauthorized finalize 0</a:t>
+                      </a:r>
+                    </a:p>
+                  </a:txBody>
+                  <a:tcPr marL="82296" marR="82296" marT="45720" marB="45720">
+                    <a:solidFill>
+                      <a:srgbClr val="0E1D30"/>
+                    </a:solidFill>
+                  </a:tcPr>
+                </a:tc>
+                <a:tc>
+                  <a:txBody>
+                    <a:bodyPr/>
+                    <a:lstStyle/>
+                    <a:p>
+                      <a:pPr algn="ctr"/>
+                      <a:r>
+                        <a:rPr sz="1050" b="0" lang="ko-KR">
+                          <a:solidFill>
+                            <a:srgbClr val="9AF56D"/>
+                          </a:solidFill>
+                          <a:latin typeface="DejaVu Sans Mono"/>
+                          <a:ea typeface="DejaVu Sans Mono"/>
+                        </a:rPr>
+                        <a:t>모델이 승인 생성 불가</a:t>
+                      </a:r>
+                    </a:p>
+                  </a:txBody>
+                  <a:tcPr marL="82296" marR="82296" marT="45720" marB="45720">
+                    <a:solidFill>
+                      <a:srgbClr val="0E1D30"/>
+                    </a:solidFill>
+                  </a:tcPr>
+                </a:tc>
+              </a:tr>
+              <a:tr h="597408">
+                <a:tc>
+                  <a:txBody>
+                    <a:bodyPr/>
+                    <a:lstStyle/>
+                    <a:p>
+                      <a:pPr algn="l"/>
+                      <a:r>
+                        <a:rPr sz="1050" b="0" lang="ko-KR">
+                          <a:solidFill>
+                            <a:srgbClr val="F3F7FD"/>
+                          </a:solidFill>
+                          <a:latin typeface="Noto Sans KR"/>
+                          <a:ea typeface="Noto Sans KR"/>
+                        </a:rPr>
+                        <a:t>Delivery</a:t>
+                      </a:r>
+                    </a:p>
+                  </a:txBody>
+                  <a:tcPr marL="82296" marR="82296" marT="45720" marB="45720">
+                    <a:solidFill>
+                      <a:srgbClr val="0E1D30"/>
+                    </a:solidFill>
+                  </a:tcPr>
+                </a:tc>
+                <a:tc>
+                  <a:txBody>
+                    <a:bodyPr/>
+                    <a:lstStyle/>
+                    <a:p>
+                      <a:pPr algn="ctr"/>
+                      <a:r>
+                        <a:rPr sz="1050" b="0" lang="ko-KR">
+                          <a:solidFill>
+                            <a:srgbClr val="9AF56D"/>
+                          </a:solidFill>
+                          <a:latin typeface="DejaVu Sans Mono"/>
+                          <a:ea typeface="DejaVu Sans Mono"/>
+                        </a:rPr>
+                        <a:t>FastAPI + Docker + CI + trace</a:t>
+                      </a:r>
+                    </a:p>
+                  </a:txBody>
+                  <a:tcPr marL="82296" marR="82296" marT="45720" marB="45720">
+                    <a:solidFill>
+                      <a:srgbClr val="0E1D30"/>
+                    </a:solidFill>
+                  </a:tcPr>
+                </a:tc>
+                <a:tc>
+                  <a:txBody>
+                    <a:bodyPr/>
+                    <a:lstStyle/>
+                    <a:p>
+                      <a:pPr algn="ctr"/>
+                      <a:r>
+                        <a:rPr sz="1050" b="0" lang="ko-KR">
+                          <a:solidFill>
+                            <a:srgbClr val="9AF56D"/>
+                          </a:solidFill>
+                          <a:latin typeface="DejaVu Sans Mono"/>
+                          <a:ea typeface="DejaVu Sans Mono"/>
+                        </a:rPr>
+                        <a:t>container smoke PASS</a:t>
+                      </a:r>
+                    </a:p>
+                  </a:txBody>
+                  <a:tcPr marL="82296" marR="82296" marT="45720" marB="45720">
+                    <a:solidFill>
+                      <a:srgbClr val="0E1D30"/>
+                    </a:solidFill>
+                  </a:tcPr>
+                </a:tc>
+                <a:tc>
+                  <a:txBody>
+                    <a:bodyPr/>
+                    <a:lstStyle/>
+                    <a:p>
+                      <a:pPr algn="ctr"/>
+                      <a:r>
+                        <a:rPr sz="1050" b="0" lang="ko-KR">
+                          <a:solidFill>
+                            <a:srgbClr val="9AF56D"/>
+                          </a:solidFill>
+                          <a:latin typeface="DejaVu Sans Mono"/>
+                          <a:ea typeface="DejaVu Sans Mono"/>
+                        </a:rPr>
+                        <a:t>trace_id replay</a:t>
                       </a:r>
                     </a:p>
                   </a:txBody>
@@ -4550,7 +4550,7 @@
                 <a:latin typeface="Noto Sans KR"/>
                 <a:ea typeface="Noto Sans KR"/>
               </a:rPr>
-              <a:t>NEEDS_ATTENTION은 자동 재시도하지 않으며 사람이 확인 · LLM triage NOT_NEEDED</a:t>
+              <a:t>Control PASS는 금융 법률 정확도 100%가 아니라 expected block/recovery가 관찰됐다는 의미</a:t>
             </a:r>
           </a:p>
         </p:txBody>
@@ -5270,7 +5270,7 @@
                           <a:latin typeface="Noto Sans KR"/>
                           <a:ea typeface="Noto Sans KR"/>
                         </a:rPr>
-                        <a:t>EvidenceOps Agent</a:t>
+                        <a:t>FinCompliance Agent</a:t>
                       </a:r>
                     </a:p>
                   </a:txBody>
@@ -5294,7 +5294,7 @@
                           <a:latin typeface="DejaVu Sans Mono"/>
                           <a:ea typeface="DejaVu Sans Mono"/>
                         </a:rPr>
-                        <a:t>experiment spec·argv allowlist</a:t>
+                        <a:t>strict tool schema·synthetic evidence</a:t>
                       </a:r>
                     </a:p>
                   </a:txBody>
@@ -5318,7 +5318,7 @@
                           <a:latin typeface="DejaVu Sans Mono"/>
                           <a:ea typeface="DejaVu Sans Mono"/>
                         </a:rPr>
-                        <a:t>checkpoint + hash chain</a:t>
+                        <a:t>12 adversarial controls</a:t>
                       </a:r>
                     </a:p>
                   </a:txBody>
@@ -5342,7 +5342,7 @@
                           <a:latin typeface="DejaVu Sans Mono"/>
                           <a:ea typeface="DejaVu Sans Mono"/>
                         </a:rPr>
-                        <a:t>JSON · HTML · MCP · CI</a:t>
+                        <a:t>JSON trace · API · HTML · PPTX</a:t>
                       </a:r>
                     </a:p>
                   </a:txBody>
@@ -6469,7 +6469,7 @@
                 <a:latin typeface="Noto Sans KR"/>
                 <a:ea typeface="Noto Sans KR"/>
               </a:rPr>
-              <a:t>AgentOps</a:t>
+              <a:t>Agent</a:t>
             </a:r>
           </a:p>
         </p:txBody>
@@ -6512,7 +6512,7 @@
                 <a:latin typeface="Noto Sans KR"/>
                 <a:ea typeface="Noto Sans KR"/>
               </a:rPr>
-              <a:t>Automation</a:t>
+              <a:t>Tool Use</a:t>
             </a:r>
           </a:p>
         </p:txBody>
@@ -6555,7 +6555,7 @@
                 <a:latin typeface="Noto Sans KR"/>
                 <a:ea typeface="Noto Sans KR"/>
               </a:rPr>
-              <a:t>policy gate, state machine, checkpoint·resume, MCP, tamper-evident audit</a:t>
+              <a:t>function calling loop, strict guardrails, prompt-injection defense, out-of-band HITL</a:t>
             </a:r>
           </a:p>
         </p:txBody>
@@ -7320,7 +7320,7 @@
                           <a:latin typeface="Noto Sans KR"/>
                           <a:ea typeface="Noto Sans KR"/>
                         </a:rPr>
-                        <a:t>EvidenceOps Agent</a:t>
+                        <a:t>FinCompliance Agent</a:t>
                       </a:r>
                     </a:p>
                   </a:txBody>
@@ -7344,7 +7344,7 @@
                           <a:latin typeface="DejaVu Sans Mono"/>
                           <a:ea typeface="DejaVu Sans Mono"/>
                         </a:rPr>
-                        <a:t>12 tests + 6/6 jobs PASS</a:t>
+                        <a:t>12 tests + 12/12 controls PASS</a:t>
                       </a:r>
                     </a:p>
                   </a:txBody>
@@ -7368,7 +7368,7 @@
                           <a:latin typeface="DejaVu Sans Mono"/>
                           <a:ea typeface="DejaVu Sans Mono"/>
                         </a:rPr>
-                        <a:t>HTML · PPTX · evidence JSON</a:t>
+                        <a:t>HTML · PPTX · trace JSON</a:t>
                       </a:r>
                     </a:p>
                   </a:txBody>
@@ -7392,7 +7392,7 @@
                           <a:latin typeface="DejaVu Sans Mono"/>
                           <a:ea typeface="DejaVu Sans Mono"/>
                         </a:rPr>
-                        <a:t>local main</a:t>
+                        <a:t>public main</a:t>
                       </a:r>
                     </a:p>
                   </a:txBody>
@@ -7490,7 +7490,7 @@
                 <a:latin typeface="Noto Sans KR"/>
                 <a:ea typeface="Noto Sans KR"/>
               </a:rPr>
-              <a:t>K-VoiceBench와 EvidenceOps는 나중에 GitHub 저장소를 만든 뒤 원격만 연결하면 되는 상태</a:t>
+              <a:t>FinCompliance Agent는 public main · K-VoiceBench와 EvidenceOps는 원격 연결 대기</a:t>
             </a:r>
           </a:p>
         </p:txBody>
@@ -7688,7 +7688,7 @@
                 <a:latin typeface="Noto Sans KR"/>
                 <a:ea typeface="Noto Sans KR"/>
               </a:rPr>
-              <a:t>Build · Measure · Operate · Automate</a:t>
+              <a:t>Build · Measure · Operate · Act</a:t>
             </a:r>
           </a:p>
         </p:txBody>
@@ -7731,7 +7731,7 @@
                 <a:latin typeface="Noto Sans KR"/>
                 <a:ea typeface="Noto Sans KR"/>
               </a:rPr>
-              <a:t>금융 LLMOps, 양자화 원인 분석, 한국어 음성 평가를 거쳐 제한된 GPU의 AI 실험을 정책과 증거로 자동화했습니다.</a:t>
+              <a:t>금융 LLMOps, 양자화 원인 분석, 한국어 음성 평가를 거쳐 모델이 근거와 권한 안에서 행동하는 Agent를 구현했습니다.</a:t>
             </a:r>
           </a:p>
         </p:txBody>
@@ -9069,7 +9069,7 @@
                 <a:latin typeface="Noto Sans KR"/>
                 <a:ea typeface="Noto Sans KR"/>
               </a:rPr>
-              <a:t>04 EvidenceOps Agent</a:t>
+              <a:t>04 FinCompliance Agent</a:t>
             </a:r>
           </a:p>
         </p:txBody>
@@ -9112,7 +9112,7 @@
                 <a:latin typeface="Noto Sans KR"/>
                 <a:ea typeface="Noto Sans KR"/>
               </a:rPr>
-              <a:t>자동화</a:t>
+              <a:t>행동</a:t>
             </a:r>
           </a:p>
         </p:txBody>
@@ -9155,7 +9155,7 @@
                 <a:latin typeface="Noto Sans KR"/>
                 <a:ea typeface="Noto Sans KR"/>
               </a:rPr>
-              <a:t>긴 AI 실험을 사람이 밤새 지키지 않아도 정책·큐·증거로 어떻게 운영할까?</a:t>
+              <a:t>금융 준법 검토에서 모델이 도구를 선택하되 권한과 근거를 코드로 어떻게 강제할까?</a:t>
             </a:r>
           </a:p>
         </p:txBody>
@@ -17906,7 +17906,7 @@
                 <a:latin typeface="Noto Sans KR"/>
                 <a:ea typeface="Noto Sans KR"/>
               </a:rPr>
-              <a:t>PROJECT 04 · EVIDENCEOPS AGENT</a:t>
+              <a:t>PROJECT 04 · FINCOMPLIANCE AGENT</a:t>
             </a:r>
           </a:p>
         </p:txBody>
@@ -17949,7 +17949,7 @@
                 <a:latin typeface="Noto Sans KR"/>
                 <a:ea typeface="Noto Sans KR"/>
               </a:rPr>
-              <a:t>AI 실험 운영을 사람의 밤샘에서 분리</a:t>
+              <a:t>모델이 선택하고 애플리케이션이 통제</a:t>
             </a:r>
           </a:p>
         </p:txBody>
@@ -17992,7 +17992,7 @@
                 <a:latin typeface="Noto Sans KR"/>
                 <a:ea typeface="Noto Sans KR"/>
               </a:rPr>
-              <a:t>허용된 도구만 순차 실행하고 interruption 이후 checkpoint에서 재개합니다.</a:t>
+              <a:t>LLM이 도구 결과를 관찰해 다음 행동을 고르지만 실행 권한은 policy engine이 강제합니다.</a:t>
             </a:r>
           </a:p>
         </p:txBody>
@@ -18123,7 +18123,7 @@
                 <a:latin typeface="Noto Sans KR"/>
                 <a:ea typeface="Noto Sans KR"/>
               </a:rPr>
-              <a:t>Discover</a:t>
+              <a:t>Request</a:t>
             </a:r>
           </a:p>
         </p:txBody>
@@ -18254,7 +18254,7 @@
                 <a:latin typeface="Noto Sans KR"/>
                 <a:ea typeface="Noto Sans KR"/>
               </a:rPr>
-              <a:t>Policy Gate</a:t>
+              <a:t>LLM Chooses</a:t>
             </a:r>
           </a:p>
         </p:txBody>
@@ -18385,7 +18385,7 @@
                 <a:latin typeface="Noto Sans KR"/>
                 <a:ea typeface="Noto Sans KR"/>
               </a:rPr>
-              <a:t>Sequential Queue</a:t>
+              <a:t>Strict Policy</a:t>
             </a:r>
           </a:p>
         </p:txBody>
@@ -18647,7 +18647,7 @@
                 <a:latin typeface="Noto Sans KR"/>
                 <a:ea typeface="Noto Sans KR"/>
               </a:rPr>
-              <a:t>Observe·Triage</a:t>
+              <a:t>Observe·Replan</a:t>
             </a:r>
           </a:p>
         </p:txBody>
@@ -18778,7 +18778,7 @@
                 <a:latin typeface="Noto Sans KR"/>
                 <a:ea typeface="Noto Sans KR"/>
               </a:rPr>
-              <a:t>Evidence Pack</a:t>
+              <a:t>HITL</a:t>
             </a:r>
           </a:p>
         </p:txBody>
@@ -18866,7 +18866,7 @@
                 <a:latin typeface="Noto Sans KR"/>
                 <a:ea typeface="Noto Sans KR"/>
               </a:rPr>
-              <a:t>Portfolio jobs</a:t>
+              <a:t>Strict tools</a:t>
             </a:r>
           </a:p>
         </p:txBody>
@@ -18909,7 +18909,7 @@
                 <a:latin typeface="DejaVu Sans Mono"/>
                 <a:ea typeface="DejaVu Sans Mono"/>
               </a:rPr>
-              <a:t>6 / 6 PASS</a:t>
+              <a:t>9</a:t>
             </a:r>
           </a:p>
         </p:txBody>
@@ -18997,7 +18997,7 @@
                 <a:latin typeface="Noto Sans KR"/>
                 <a:ea typeface="Noto Sans KR"/>
               </a:rPr>
-              <a:t>Unit tests</a:t>
+              <a:t>Policy eval</a:t>
             </a:r>
           </a:p>
         </p:txBody>
@@ -19040,7 +19040,7 @@
                 <a:latin typeface="DejaVu Sans Mono"/>
                 <a:ea typeface="DejaVu Sans Mono"/>
               </a:rPr>
-              <a:t>12</a:t>
+              <a:t>12 / 12 PASS</a:t>
             </a:r>
           </a:p>
         </p:txBody>
@@ -19128,7 +19128,7 @@
                 <a:latin typeface="Noto Sans KR"/>
                 <a:ea typeface="Noto Sans KR"/>
               </a:rPr>
-              <a:t>GPU policy</a:t>
+              <a:t>Automated tests</a:t>
             </a:r>
           </a:p>
         </p:txBody>
@@ -19171,7 +19171,7 @@
                 <a:latin typeface="DejaVu Sans Mono"/>
                 <a:ea typeface="DejaVu Sans Mono"/>
               </a:rPr>
-              <a:t>GPU 1 only</a:t>
+              <a:t>12 / 12</a:t>
             </a:r>
           </a:p>
         </p:txBody>
@@ -19259,7 +19259,7 @@
                 <a:latin typeface="Noto Sans KR"/>
                 <a:ea typeface="Noto Sans KR"/>
               </a:rPr>
-              <a:t>LLM action</a:t>
+              <a:t>Unauthorized finalize</a:t>
             </a:r>
           </a:p>
         </p:txBody>
@@ -19302,7 +19302,7 @@
                 <a:latin typeface="DejaVu Sans Mono"/>
                 <a:ea typeface="DejaVu Sans Mono"/>
               </a:rPr>
-              <a:t>Advisory</a:t>
+              <a:t>0</a:t>
             </a:r>
           </a:p>
         </p:txBody>
@@ -19390,7 +19390,7 @@
                 <a:latin typeface="Noto Sans KR"/>
                 <a:ea typeface="Noto Sans KR"/>
               </a:rPr>
-              <a:t>CPU job은 CUDA를 볼 수 없고 GPU job은 물리 GPU 1번 exclusive lock</a:t>
+              <a:t>실제 OpenAI model lane은 API key 미설정으로 NOT_EXECUTED · deterministic control lane 완료</a:t>
             </a:r>
           </a:p>
         </p:txBody>

</xml_diff>